<commit_message>
Deck: place 3D models by their frame only, and keep frames on the slide
The model markup repeated each frame's position inside the model itself.
If PowerPoint reads that inner position relative to the frame, the offset
doubles and the models land far to the right. The inner transform is
dropped, so the frame alone places each model. The protein scenes are also
zoomed out a little so every frame stays within the slide; the second BRD4
still starts below the slide on purpose, to slide in.

Co-Authored-By: Claude Opus 5.5 <noreply@anthropic.com>
Claude-Session: https://claude.ai/code/session_016enSDyYsE7QESGUbDiHchT
</commit_message>
<xml_diff>
--- a/oyster/deck/oyster-selftac-morph.pptx
+++ b/oyster/deck/oyster-selftac-morph.pptx
@@ -1636,10 +1636,6 @@
               <a:graphicData uri="http://schemas.microsoft.com/office/drawing/2017/model3d">
                 <am3d:model3d r:embed="rId9">
                   <am3d:spPr>
-                    <a:xfrm>
-                      <a:off x="6994630" y="3540735"/>
-                      <a:ext cx="1004404" cy="1004404"/>
-                    </a:xfrm>
                     <a:prstGeom prst="rect">
                       <a:avLst/>
                     </a:prstGeom>
@@ -1742,10 +1738,6 @@
               <a:graphicData uri="http://schemas.microsoft.com/office/drawing/2017/model3d">
                 <am3d:model3d r:embed="rId10">
                   <am3d:spPr>
-                    <a:xfrm>
-                      <a:off x="6068738" y="1981718"/>
-                      <a:ext cx="2681028" cy="2681028"/>
-                    </a:xfrm>
                     <a:prstGeom prst="rect">
                       <a:avLst/>
                     </a:prstGeom>
@@ -1848,10 +1840,6 @@
               <a:graphicData uri="http://schemas.microsoft.com/office/drawing/2017/model3d">
                 <am3d:model3d r:embed="rId11">
                   <am3d:spPr>
-                    <a:xfrm>
-                      <a:off x="6380251" y="957511"/>
-                      <a:ext cx="4424993" cy="4424993"/>
-                    </a:xfrm>
                     <a:prstGeom prst="rect">
                       <a:avLst/>
                     </a:prstGeom>
@@ -2080,10 +2068,6 @@
               <a:graphicData uri="http://schemas.microsoft.com/office/drawing/2017/model3d">
                 <am3d:model3d r:embed="rId8">
                   <am3d:spPr>
-                    <a:xfrm>
-                      <a:off x="6180473" y="694298"/>
-                      <a:ext cx="4867493" cy="4867493"/>
-                    </a:xfrm>
                     <a:prstGeom prst="rect">
                       <a:avLst/>
                     </a:prstGeom>
@@ -2186,10 +2170,6 @@
               <a:graphicData uri="http://schemas.microsoft.com/office/drawing/2017/model3d">
                 <am3d:model3d r:embed="rId9">
                   <am3d:spPr>
-                    <a:xfrm>
-                      <a:off x="6760509" y="3588322"/>
-                      <a:ext cx="1104844" cy="1104844"/>
-                    </a:xfrm>
                     <a:prstGeom prst="rect">
                       <a:avLst/>
                     </a:prstGeom>
@@ -2292,10 +2272,6 @@
               <a:graphicData uri="http://schemas.microsoft.com/office/drawing/2017/model3d">
                 <am3d:model3d r:embed="rId10">
                   <am3d:spPr>
-                    <a:xfrm>
-                      <a:off x="5913215" y="1889630"/>
-                      <a:ext cx="2949131" cy="2949131"/>
-                    </a:xfrm>
                     <a:prstGeom prst="rect">
                       <a:avLst/>
                     </a:prstGeom>
@@ -2998,10 +2974,6 @@
               <a:graphicData uri="http://schemas.microsoft.com/office/drawing/2017/model3d">
                 <am3d:model3d r:embed="rId6">
                   <am3d:spPr>
-                    <a:xfrm>
-                      <a:off x="8826394" y="1916202"/>
-                      <a:ext cx="3318745" cy="3318745"/>
-                    </a:xfrm>
                     <a:prstGeom prst="rect">
                       <a:avLst/>
                     </a:prstGeom>
@@ -3104,10 +3076,6 @@
               <a:graphicData uri="http://schemas.microsoft.com/office/drawing/2017/model3d">
                 <am3d:model3d r:embed="rId7">
                   <am3d:spPr>
-                    <a:xfrm>
-                      <a:off x="4510848" y="1911279"/>
-                      <a:ext cx="2010771" cy="2010771"/>
-                    </a:xfrm>
                     <a:prstGeom prst="rect">
                       <a:avLst/>
                     </a:prstGeom>
@@ -3868,10 +3836,6 @@
               <a:graphicData uri="http://schemas.microsoft.com/office/drawing/2017/model3d">
                 <am3d:model3d r:embed="rId6">
                   <am3d:spPr>
-                    <a:xfrm>
-                      <a:off x="5480811" y="2369749"/>
-                      <a:ext cx="1340514" cy="1340514"/>
-                    </a:xfrm>
                     <a:prstGeom prst="rect">
                       <a:avLst/>
                     </a:prstGeom>
@@ -3974,10 +3938,6 @@
               <a:graphicData uri="http://schemas.microsoft.com/office/drawing/2017/model3d">
                 <am3d:model3d r:embed="rId7">
                   <am3d:spPr>
-                    <a:xfrm>
-                      <a:off x="8744683" y="2592997"/>
-                      <a:ext cx="2212497" cy="2212497"/>
-                    </a:xfrm>
                     <a:prstGeom prst="rect">
                       <a:avLst/>
                     </a:prstGeom>
@@ -4670,8 +4630,8 @@
         </p:blipFill>
         <p:spPr>
           <a:xfrm>
-            <a:off x="6633845" y="2985657"/>
-            <a:ext cx="1450238" cy="1450238"/>
+            <a:off x="6970030" y="3049705"/>
+            <a:ext cx="1093622" cy="1093622"/>
           </a:xfrm>
           <a:prstGeom prst="rect">
             <a:avLst/>
@@ -4689,17 +4649,13 @@
               <p:nvPr/>
             </p:nvGraphicFramePr>
             <p:xfrm>
-              <a:off x="7205792" y="3557604"/>
-              <a:ext cx="306343" cy="306343"/>
+              <a:off x="7401335" y="3481010"/>
+              <a:ext cx="231013" cy="231013"/>
             </p:xfrm>
             <a:graphic>
               <a:graphicData uri="http://schemas.microsoft.com/office/drawing/2017/model3d">
                 <am3d:model3d r:embed="rId10">
                   <am3d:spPr>
-                    <a:xfrm>
-                      <a:off x="7205792" y="3557604"/>
-                      <a:ext cx="306343" cy="306343"/>
-                    </a:xfrm>
                     <a:prstGeom prst="rect">
                       <a:avLst/>
                     </a:prstGeom>
@@ -4724,7 +4680,7 @@
                   <am3d:raster rName="Office3DRenderer" rVer="16.0.8326">
                     <am3d:blip r:embed="rId3"/>
                   </am3d:raster>
-                  <am3d:objViewport viewportSz="306343"/>
+                  <am3d:objViewport viewportSz="231013"/>
                   <am3d:ambientLight>
                     <am3d:clr>
                       <a:scrgbClr r="50000" g="50000" b="50000"/>
@@ -4774,8 +4730,8 @@
             </p:blipFill>
             <p:spPr>
               <a:xfrm>
-                <a:off x="7205792" y="3557604"/>
-                <a:ext cx="306343" cy="306343"/>
+                <a:off x="7401335" y="3481010"/>
+                <a:ext cx="231013" cy="231013"/>
               </a:xfrm>
               <a:prstGeom prst="rect">
                 <a:avLst/>
@@ -4795,17 +4751,13 @@
               <p:nvPr/>
             </p:nvGraphicFramePr>
             <p:xfrm>
-              <a:off x="7052383" y="2763150"/>
-              <a:ext cx="1349623" cy="1349623"/>
+              <a:off x="7285649" y="2881913"/>
+              <a:ext cx="1017748" cy="1017748"/>
             </p:xfrm>
             <a:graphic>
               <a:graphicData uri="http://schemas.microsoft.com/office/drawing/2017/model3d">
                 <am3d:model3d r:embed="rId11">
                   <am3d:spPr>
-                    <a:xfrm>
-                      <a:off x="7052383" y="2763150"/>
-                      <a:ext cx="1349623" cy="1349623"/>
-                    </a:xfrm>
                     <a:prstGeom prst="rect">
                       <a:avLst/>
                     </a:prstGeom>
@@ -4830,7 +4782,7 @@
                   <am3d:raster rName="Office3DRenderer" rVer="16.0.8326">
                     <am3d:blip r:embed="rId4"/>
                   </am3d:raster>
-                  <am3d:objViewport viewportSz="1349623"/>
+                  <am3d:objViewport viewportSz="1017748"/>
                   <am3d:ambientLight>
                     <am3d:clr>
                       <a:scrgbClr r="50000" g="50000" b="50000"/>
@@ -4880,8 +4832,8 @@
             </p:blipFill>
             <p:spPr>
               <a:xfrm>
-                <a:off x="7052383" y="2763150"/>
-                <a:ext cx="1349623" cy="1349623"/>
+                <a:off x="7285649" y="2881913"/>
+                <a:ext cx="1017748" cy="1017748"/>
               </a:xfrm>
               <a:prstGeom prst="rect">
                 <a:avLst/>
@@ -4901,17 +4853,13 @@
               <p:nvPr/>
             </p:nvGraphicFramePr>
             <p:xfrm>
-              <a:off x="6950310" y="3082352"/>
-              <a:ext cx="817714" cy="817714"/>
+              <a:off x="7208677" y="3122623"/>
+              <a:ext cx="616637" cy="616637"/>
             </p:xfrm>
             <a:graphic>
               <a:graphicData uri="http://schemas.microsoft.com/office/drawing/2017/model3d">
                 <am3d:model3d r:embed="rId12">
                   <am3d:spPr>
-                    <a:xfrm>
-                      <a:off x="6950310" y="3082352"/>
-                      <a:ext cx="817714" cy="817714"/>
-                    </a:xfrm>
                     <a:prstGeom prst="rect">
                       <a:avLst/>
                     </a:prstGeom>
@@ -4936,7 +4884,7 @@
                   <am3d:raster rName="Office3DRenderer" rVer="16.0.8326">
                     <am3d:blip r:embed="rId5"/>
                   </am3d:raster>
-                  <am3d:objViewport viewportSz="817714"/>
+                  <am3d:objViewport viewportSz="616637"/>
                   <am3d:ambientLight>
                     <am3d:clr>
                       <a:scrgbClr r="50000" g="50000" b="50000"/>
@@ -4986,8 +4934,8 @@
             </p:blipFill>
             <p:spPr>
               <a:xfrm>
-                <a:off x="6950310" y="3082352"/>
-                <a:ext cx="817714" cy="817714"/>
+                <a:off x="7208677" y="3122623"/>
+                <a:ext cx="616637" cy="616637"/>
               </a:xfrm>
               <a:prstGeom prst="rect">
                 <a:avLst/>
@@ -5007,17 +4955,13 @@
               <p:nvPr/>
             </p:nvGraphicFramePr>
             <p:xfrm>
-              <a:off x="3997348" y="1143833"/>
-              <a:ext cx="4561250" cy="4561250"/>
+              <a:off x="4981853" y="1660789"/>
+              <a:ext cx="3439631" cy="3439631"/>
             </p:xfrm>
             <a:graphic>
               <a:graphicData uri="http://schemas.microsoft.com/office/drawing/2017/model3d">
                 <am3d:model3d r:embed="rId13">
                   <am3d:spPr>
-                    <a:xfrm>
-                      <a:off x="3997348" y="1143833"/>
-                      <a:ext cx="4561250" cy="4561250"/>
-                    </a:xfrm>
                     <a:prstGeom prst="rect">
                       <a:avLst/>
                     </a:prstGeom>
@@ -5042,7 +4986,7 @@
                   <am3d:raster rName="Office3DRenderer" rVer="16.0.8326">
                     <am3d:blip r:embed="rId6"/>
                   </am3d:raster>
-                  <am3d:objViewport viewportSz="4561250"/>
+                  <am3d:objViewport viewportSz="3439631"/>
                   <am3d:ambientLight>
                     <am3d:clr>
                       <a:scrgbClr r="50000" g="50000" b="50000"/>
@@ -5092,8 +5036,8 @@
             </p:blipFill>
             <p:spPr>
               <a:xfrm>
-                <a:off x="3997348" y="1143833"/>
-                <a:ext cx="4561250" cy="4561250"/>
+                <a:off x="4981853" y="1660789"/>
+                <a:ext cx="3439631" cy="3439631"/>
               </a:xfrm>
               <a:prstGeom prst="rect">
                 <a:avLst/>
@@ -5113,17 +5057,13 @@
               <p:nvPr/>
             </p:nvGraphicFramePr>
             <p:xfrm>
-              <a:off x="6068474" y="-587770"/>
-              <a:ext cx="7311105" cy="7311105"/>
+              <a:off x="6543686" y="354990"/>
+              <a:ext cx="5513292" cy="5513292"/>
             </p:xfrm>
             <a:graphic>
               <a:graphicData uri="http://schemas.microsoft.com/office/drawing/2017/model3d">
                 <am3d:model3d r:embed="rId14">
                   <am3d:spPr>
-                    <a:xfrm>
-                      <a:off x="6068474" y="-587770"/>
-                      <a:ext cx="7311105" cy="7311105"/>
-                    </a:xfrm>
                     <a:prstGeom prst="rect">
                       <a:avLst/>
                     </a:prstGeom>
@@ -5148,7 +5088,7 @@
                   <am3d:raster rName="Office3DRenderer" rVer="16.0.8326">
                     <am3d:blip r:embed="rId7"/>
                   </am3d:raster>
-                  <am3d:objViewport viewportSz="7311105"/>
+                  <am3d:objViewport viewportSz="5513292"/>
                   <am3d:ambientLight>
                     <am3d:clr>
                       <a:scrgbClr r="50000" g="50000" b="50000"/>
@@ -5198,8 +5138,8 @@
             </p:blipFill>
             <p:spPr>
               <a:xfrm>
-                <a:off x="6068474" y="-587770"/>
-                <a:ext cx="7311105" cy="7311105"/>
+                <a:off x="6543686" y="354990"/>
+                <a:ext cx="5513292" cy="5513292"/>
               </a:xfrm>
               <a:prstGeom prst="rect">
                 <a:avLst/>
@@ -5812,8 +5752,8 @@
         </p:blipFill>
         <p:spPr>
           <a:xfrm>
-            <a:off x="6693616" y="2962838"/>
-            <a:ext cx="1450238" cy="1450238"/>
+            <a:off x="7015104" y="3032497"/>
+            <a:ext cx="1093622" cy="1093622"/>
           </a:xfrm>
           <a:prstGeom prst="rect">
             <a:avLst/>
@@ -5831,17 +5771,13 @@
               <p:nvPr/>
             </p:nvGraphicFramePr>
             <p:xfrm>
-              <a:off x="6907473" y="1785227"/>
-              <a:ext cx="1144244" cy="1144244"/>
+              <a:off x="7176373" y="2144463"/>
+              <a:ext cx="862872" cy="862872"/>
             </p:xfrm>
             <a:graphic>
               <a:graphicData uri="http://schemas.microsoft.com/office/drawing/2017/model3d">
                 <am3d:model3d r:embed="rId15">
                   <am3d:spPr>
-                    <a:xfrm>
-                      <a:off x="6907473" y="1785227"/>
-                      <a:ext cx="1144244" cy="1144244"/>
-                    </a:xfrm>
                     <a:prstGeom prst="rect">
                       <a:avLst/>
                     </a:prstGeom>
@@ -5866,7 +5802,7 @@
                   <am3d:raster rName="Office3DRenderer" rVer="16.0.8326">
                     <am3d:blip r:embed="rId3"/>
                   </am3d:raster>
-                  <am3d:objViewport viewportSz="1144244"/>
+                  <am3d:objViewport viewportSz="862872"/>
                   <am3d:ambientLight>
                     <am3d:clr>
                       <a:scrgbClr r="50000" g="50000" b="50000"/>
@@ -5916,8 +5852,8 @@
             </p:blipFill>
             <p:spPr>
               <a:xfrm>
-                <a:off x="6907473" y="1785227"/>
-                <a:ext cx="1144244" cy="1144244"/>
+                <a:off x="7176373" y="2144463"/>
+                <a:ext cx="862872" cy="862872"/>
               </a:xfrm>
               <a:prstGeom prst="rect">
                 <a:avLst/>
@@ -5937,17 +5873,13 @@
               <p:nvPr/>
             </p:nvGraphicFramePr>
             <p:xfrm>
-              <a:off x="6740171" y="1062694"/>
-              <a:ext cx="1144244" cy="1144244"/>
+              <a:off x="7050211" y="1599602"/>
+              <a:ext cx="862872" cy="862872"/>
             </p:xfrm>
             <a:graphic>
               <a:graphicData uri="http://schemas.microsoft.com/office/drawing/2017/model3d">
                 <am3d:model3d r:embed="rId16">
                   <am3d:spPr>
-                    <a:xfrm>
-                      <a:off x="6740171" y="1062694"/>
-                      <a:ext cx="1144244" cy="1144244"/>
-                    </a:xfrm>
                     <a:prstGeom prst="rect">
                       <a:avLst/>
                     </a:prstGeom>
@@ -5972,7 +5904,7 @@
                   <am3d:raster rName="Office3DRenderer" rVer="16.0.8326">
                     <am3d:blip r:embed="rId4"/>
                   </am3d:raster>
-                  <am3d:objViewport viewportSz="1144244"/>
+                  <am3d:objViewport viewportSz="862872"/>
                   <am3d:ambientLight>
                     <am3d:clr>
                       <a:scrgbClr r="50000" g="50000" b="50000"/>
@@ -6022,8 +5954,8 @@
             </p:blipFill>
             <p:spPr>
               <a:xfrm>
-                <a:off x="6740171" y="1062694"/>
-                <a:ext cx="1144244" cy="1144244"/>
+                <a:off x="7050211" y="1599602"/>
+                <a:ext cx="862872" cy="862872"/>
               </a:xfrm>
               <a:prstGeom prst="rect">
                 <a:avLst/>
@@ -6043,17 +5975,13 @@
               <p:nvPr/>
             </p:nvGraphicFramePr>
             <p:xfrm>
-              <a:off x="7265564" y="3534785"/>
-              <a:ext cx="306343" cy="306343"/>
+              <a:off x="7446409" y="3463802"/>
+              <a:ext cx="231013" cy="231013"/>
             </p:xfrm>
             <a:graphic>
               <a:graphicData uri="http://schemas.microsoft.com/office/drawing/2017/model3d">
                 <am3d:model3d r:embed="rId17">
                   <am3d:spPr>
-                    <a:xfrm>
-                      <a:off x="7265564" y="3534785"/>
-                      <a:ext cx="306343" cy="306343"/>
-                    </a:xfrm>
                     <a:prstGeom prst="rect">
                       <a:avLst/>
                     </a:prstGeom>
@@ -6078,7 +6006,7 @@
                   <am3d:raster rName="Office3DRenderer" rVer="16.0.8326">
                     <am3d:blip r:embed="rId5"/>
                   </am3d:raster>
-                  <am3d:objViewport viewportSz="306343"/>
+                  <am3d:objViewport viewportSz="231013"/>
                   <am3d:ambientLight>
                     <am3d:clr>
                       <a:scrgbClr r="50000" g="50000" b="50000"/>
@@ -6128,8 +6056,8 @@
             </p:blipFill>
             <p:spPr>
               <a:xfrm>
-                <a:off x="7265564" y="3534785"/>
-                <a:ext cx="306343" cy="306343"/>
+                <a:off x="7446409" y="3463802"/>
+                <a:ext cx="231013" cy="231013"/>
               </a:xfrm>
               <a:prstGeom prst="rect">
                 <a:avLst/>
@@ -6149,17 +6077,13 @@
               <p:nvPr/>
             </p:nvGraphicFramePr>
             <p:xfrm>
-              <a:off x="7107814" y="2744544"/>
-              <a:ext cx="1349623" cy="1349623"/>
+              <a:off x="7327450" y="2867882"/>
+              <a:ext cx="1017748" cy="1017748"/>
             </p:xfrm>
             <a:graphic>
               <a:graphicData uri="http://schemas.microsoft.com/office/drawing/2017/model3d">
                 <am3d:model3d r:embed="rId18">
                   <am3d:spPr>
-                    <a:xfrm>
-                      <a:off x="7107814" y="2744544"/>
-                      <a:ext cx="1349623" cy="1349623"/>
-                    </a:xfrm>
                     <a:prstGeom prst="rect">
                       <a:avLst/>
                     </a:prstGeom>
@@ -6184,7 +6108,7 @@
                   <am3d:raster rName="Office3DRenderer" rVer="16.0.8326">
                     <am3d:blip r:embed="rId6"/>
                   </am3d:raster>
-                  <am3d:objViewport viewportSz="1349623"/>
+                  <am3d:objViewport viewportSz="1017748"/>
                   <am3d:ambientLight>
                     <am3d:clr>
                       <a:scrgbClr r="50000" g="50000" b="50000"/>
@@ -6234,8 +6158,8 @@
             </p:blipFill>
             <p:spPr>
               <a:xfrm>
-                <a:off x="7107814" y="2744544"/>
-                <a:ext cx="1349623" cy="1349623"/>
+                <a:off x="7327450" y="2867882"/>
+                <a:ext cx="1017748" cy="1017748"/>
               </a:xfrm>
               <a:prstGeom prst="rect">
                 <a:avLst/>
@@ -6255,17 +6179,13 @@
               <p:nvPr/>
             </p:nvGraphicFramePr>
             <p:xfrm>
-              <a:off x="7002654" y="3062168"/>
-              <a:ext cx="817714" cy="817714"/>
+              <a:off x="7248149" y="3107402"/>
+              <a:ext cx="616637" cy="616637"/>
             </p:xfrm>
             <a:graphic>
               <a:graphicData uri="http://schemas.microsoft.com/office/drawing/2017/model3d">
                 <am3d:model3d r:embed="rId19">
                   <am3d:spPr>
-                    <a:xfrm>
-                      <a:off x="7002654" y="3062168"/>
-                      <a:ext cx="817714" cy="817714"/>
-                    </a:xfrm>
                     <a:prstGeom prst="rect">
                       <a:avLst/>
                     </a:prstGeom>
@@ -6290,7 +6210,7 @@
                   <am3d:raster rName="Office3DRenderer" rVer="16.0.8326">
                     <am3d:blip r:embed="rId7"/>
                   </am3d:raster>
-                  <am3d:objViewport viewportSz="817714"/>
+                  <am3d:objViewport viewportSz="616637"/>
                   <am3d:ambientLight>
                     <am3d:clr>
                       <a:scrgbClr r="50000" g="50000" b="50000"/>
@@ -6340,8 +6260,8 @@
             </p:blipFill>
             <p:spPr>
               <a:xfrm>
-                <a:off x="7002654" y="3062168"/>
-                <a:ext cx="817714" cy="817714"/>
+                <a:off x="7248149" y="3107402"/>
+                <a:ext cx="616637" cy="616637"/>
               </a:xfrm>
               <a:prstGeom prst="rect">
                 <a:avLst/>
@@ -6361,17 +6281,13 @@
               <p:nvPr/>
             </p:nvGraphicFramePr>
             <p:xfrm>
-              <a:off x="6830515" y="1450700"/>
-              <a:ext cx="1144244" cy="1144244"/>
+              <a:off x="7118339" y="1892197"/>
+              <a:ext cx="862872" cy="862872"/>
             </p:xfrm>
             <a:graphic>
               <a:graphicData uri="http://schemas.microsoft.com/office/drawing/2017/model3d">
                 <am3d:model3d r:embed="rId20">
                   <am3d:spPr>
-                    <a:xfrm>
-                      <a:off x="6830515" y="1450700"/>
-                      <a:ext cx="1144244" cy="1144244"/>
-                    </a:xfrm>
                     <a:prstGeom prst="rect">
                       <a:avLst/>
                     </a:prstGeom>
@@ -6396,7 +6312,7 @@
                   <am3d:raster rName="Office3DRenderer" rVer="16.0.8326">
                     <am3d:blip r:embed="rId8"/>
                   </am3d:raster>
-                  <am3d:objViewport viewportSz="1144244"/>
+                  <am3d:objViewport viewportSz="862872"/>
                   <am3d:ambientLight>
                     <am3d:clr>
                       <a:scrgbClr r="50000" g="50000" b="50000"/>
@@ -6446,8 +6362,8 @@
             </p:blipFill>
             <p:spPr>
               <a:xfrm>
-                <a:off x="6830515" y="1450700"/>
-                <a:ext cx="1144244" cy="1144244"/>
+                <a:off x="7118339" y="1892197"/>
+                <a:ext cx="862872" cy="862872"/>
               </a:xfrm>
               <a:prstGeom prst="rect">
                 <a:avLst/>
@@ -6467,17 +6383,13 @@
               <p:nvPr/>
             </p:nvGraphicFramePr>
             <p:xfrm>
-              <a:off x="6663213" y="728167"/>
-              <a:ext cx="1144244" cy="1144244"/>
+              <a:off x="6992177" y="1347336"/>
+              <a:ext cx="862872" cy="862872"/>
             </p:xfrm>
             <a:graphic>
               <a:graphicData uri="http://schemas.microsoft.com/office/drawing/2017/model3d">
                 <am3d:model3d r:embed="rId21">
                   <am3d:spPr>
-                    <a:xfrm>
-                      <a:off x="6663213" y="728167"/>
-                      <a:ext cx="1144244" cy="1144244"/>
-                    </a:xfrm>
                     <a:prstGeom prst="rect">
                       <a:avLst/>
                     </a:prstGeom>
@@ -6502,7 +6414,7 @@
                   <am3d:raster rName="Office3DRenderer" rVer="16.0.8326">
                     <am3d:blip r:embed="rId9"/>
                   </am3d:raster>
-                  <am3d:objViewport viewportSz="1144244"/>
+                  <am3d:objViewport viewportSz="862872"/>
                   <am3d:ambientLight>
                     <am3d:clr>
                       <a:scrgbClr r="50000" g="50000" b="50000"/>
@@ -6552,8 +6464,8 @@
             </p:blipFill>
             <p:spPr>
               <a:xfrm>
-                <a:off x="6663213" y="728167"/>
-                <a:ext cx="1144244" cy="1144244"/>
+                <a:off x="6992177" y="1347336"/>
+                <a:ext cx="862872" cy="862872"/>
               </a:xfrm>
               <a:prstGeom prst="rect">
                 <a:avLst/>
@@ -6573,17 +6485,13 @@
               <p:nvPr/>
             </p:nvGraphicFramePr>
             <p:xfrm>
-              <a:off x="4022248" y="1124902"/>
-              <a:ext cx="4561250" cy="4561250"/>
+              <a:off x="5000630" y="1646513"/>
+              <a:ext cx="3439631" cy="3439631"/>
             </p:xfrm>
             <a:graphic>
               <a:graphicData uri="http://schemas.microsoft.com/office/drawing/2017/model3d">
                 <am3d:model3d r:embed="rId22">
                   <am3d:spPr>
-                    <a:xfrm>
-                      <a:off x="4022248" y="1124902"/>
-                      <a:ext cx="4561250" cy="4561250"/>
-                    </a:xfrm>
                     <a:prstGeom prst="rect">
                       <a:avLst/>
                     </a:prstGeom>
@@ -6608,7 +6516,7 @@
                   <am3d:raster rName="Office3DRenderer" rVer="16.0.8326">
                     <am3d:blip r:embed="rId10"/>
                   </am3d:raster>
-                  <am3d:objViewport viewportSz="4561250"/>
+                  <am3d:objViewport viewportSz="3439631"/>
                   <am3d:ambientLight>
                     <am3d:clr>
                       <a:scrgbClr r="50000" g="50000" b="50000"/>
@@ -6658,8 +6566,8 @@
             </p:blipFill>
             <p:spPr>
               <a:xfrm>
-                <a:off x="4022248" y="1124902"/>
-                <a:ext cx="4561250" cy="4561250"/>
+                <a:off x="5000630" y="1646513"/>
+                <a:ext cx="3439631" cy="3439631"/>
               </a:xfrm>
               <a:prstGeom prst="rect">
                 <a:avLst/>
@@ -6679,17 +6587,13 @@
               <p:nvPr/>
             </p:nvGraphicFramePr>
             <p:xfrm>
-              <a:off x="7062419" y="213067"/>
-              <a:ext cx="3164648" cy="3164648"/>
+              <a:off x="7293217" y="958900"/>
+              <a:ext cx="2386456" cy="2386456"/>
             </p:xfrm>
             <a:graphic>
               <a:graphicData uri="http://schemas.microsoft.com/office/drawing/2017/model3d">
                 <am3d:model3d r:embed="rId23">
                   <am3d:spPr>
-                    <a:xfrm>
-                      <a:off x="7062419" y="213067"/>
-                      <a:ext cx="3164648" cy="3164648"/>
-                    </a:xfrm>
                     <a:prstGeom prst="rect">
                       <a:avLst/>
                     </a:prstGeom>
@@ -6714,7 +6618,7 @@
                   <am3d:raster rName="Office3DRenderer" rVer="16.0.8326">
                     <am3d:blip r:embed="rId11"/>
                   </am3d:raster>
-                  <am3d:objViewport viewportSz="3164648"/>
+                  <am3d:objViewport viewportSz="2386456"/>
                   <am3d:ambientLight>
                     <am3d:clr>
                       <a:scrgbClr r="50000" g="50000" b="50000"/>
@@ -6764,8 +6668,8 @@
             </p:blipFill>
             <p:spPr>
               <a:xfrm>
-                <a:off x="7062419" y="213067"/>
-                <a:ext cx="3164648" cy="3164648"/>
+                <a:off x="7293217" y="958900"/>
+                <a:ext cx="2386456" cy="2386456"/>
               </a:xfrm>
               <a:prstGeom prst="rect">
                 <a:avLst/>
@@ -6785,17 +6689,13 @@
               <p:nvPr/>
             </p:nvGraphicFramePr>
             <p:xfrm>
-              <a:off x="6043574" y="-568840"/>
-              <a:ext cx="7311105" cy="7311105"/>
+              <a:off x="6524908" y="369265"/>
+              <a:ext cx="5513292" cy="5513292"/>
             </p:xfrm>
             <a:graphic>
               <a:graphicData uri="http://schemas.microsoft.com/office/drawing/2017/model3d">
                 <am3d:model3d r:embed="rId24">
                   <am3d:spPr>
-                    <a:xfrm>
-                      <a:off x="6043574" y="-568840"/>
-                      <a:ext cx="7311105" cy="7311105"/>
-                    </a:xfrm>
                     <a:prstGeom prst="rect">
                       <a:avLst/>
                     </a:prstGeom>
@@ -6820,7 +6720,7 @@
                   <am3d:raster rName="Office3DRenderer" rVer="16.0.8326">
                     <am3d:blip r:embed="rId12"/>
                   </am3d:raster>
-                  <am3d:objViewport viewportSz="7311105"/>
+                  <am3d:objViewport viewportSz="5513292"/>
                   <am3d:ambientLight>
                     <am3d:clr>
                       <a:scrgbClr r="50000" g="50000" b="50000"/>
@@ -6870,8 +6770,8 @@
             </p:blipFill>
             <p:spPr>
               <a:xfrm>
-                <a:off x="6043574" y="-568840"/>
-                <a:ext cx="7311105" cy="7311105"/>
+                <a:off x="6524908" y="369265"/>
+                <a:ext cx="5513292" cy="5513292"/>
               </a:xfrm>
               <a:prstGeom prst="rect">
                 <a:avLst/>
@@ -7480,8 +7380,8 @@
         </p:blipFill>
         <p:spPr>
           <a:xfrm>
-            <a:off x="7977553" y="2429892"/>
-            <a:ext cx="1117397" cy="1117397"/>
+            <a:off x="7761984" y="2550406"/>
+            <a:ext cx="950976" cy="950976"/>
           </a:xfrm>
           <a:prstGeom prst="rect">
             <a:avLst/>
@@ -7499,17 +7399,13 @@
               <p:nvPr/>
             </p:nvGraphicFramePr>
             <p:xfrm>
-              <a:off x="4616983" y="6142772"/>
-              <a:ext cx="3514406" cy="3514406"/>
+              <a:off x="4901925" y="5710305"/>
+              <a:ext cx="2990984" cy="2990984"/>
             </p:xfrm>
             <a:graphic>
               <a:graphicData uri="http://schemas.microsoft.com/office/drawing/2017/model3d">
                 <am3d:model3d r:embed="rId16">
                   <am3d:spPr>
-                    <a:xfrm>
-                      <a:off x="4616983" y="6142772"/>
-                      <a:ext cx="3514406" cy="3514406"/>
-                    </a:xfrm>
                     <a:prstGeom prst="rect">
                       <a:avLst/>
                     </a:prstGeom>
@@ -7534,7 +7430,7 @@
                   <am3d:raster rName="Office3DRenderer" rVer="16.0.8326">
                     <am3d:blip r:embed="rId3"/>
                   </am3d:raster>
-                  <am3d:objViewport viewportSz="3514406"/>
+                  <am3d:objViewport viewportSz="2990984"/>
                   <am3d:ambientLight>
                     <am3d:clr>
                       <a:scrgbClr r="50000" g="50000" b="50000"/>
@@ -7584,8 +7480,8 @@
             </p:blipFill>
             <p:spPr>
               <a:xfrm>
-                <a:off x="4616983" y="6142772"/>
-                <a:ext cx="3514406" cy="3514406"/>
+                <a:off x="4901925" y="5710305"/>
+                <a:ext cx="2990984" cy="2990984"/>
               </a:xfrm>
               <a:prstGeom prst="rect">
                 <a:avLst/>
@@ -7605,17 +7501,13 @@
               <p:nvPr/>
             </p:nvGraphicFramePr>
             <p:xfrm>
-              <a:off x="8418234" y="2870573"/>
-              <a:ext cx="236035" cy="236035"/>
+              <a:off x="8137032" y="2925454"/>
+              <a:ext cx="200881" cy="200881"/>
             </p:xfrm>
             <a:graphic>
               <a:graphicData uri="http://schemas.microsoft.com/office/drawing/2017/model3d">
                 <am3d:model3d r:embed="rId17">
                   <am3d:spPr>
-                    <a:xfrm>
-                      <a:off x="8418234" y="2870573"/>
-                      <a:ext cx="236035" cy="236035"/>
-                    </a:xfrm>
                     <a:prstGeom prst="rect">
                       <a:avLst/>
                     </a:prstGeom>
@@ -7640,7 +7532,7 @@
                   <am3d:raster rName="Office3DRenderer" rVer="16.0.8326">
                     <am3d:blip r:embed="rId4"/>
                   </am3d:raster>
-                  <am3d:objViewport viewportSz="236035"/>
+                  <am3d:objViewport viewportSz="200881"/>
                   <am3d:ambientLight>
                     <am3d:clr>
                       <a:scrgbClr r="50000" g="50000" b="50000"/>
@@ -7690,8 +7582,8 @@
             </p:blipFill>
             <p:spPr>
               <a:xfrm>
-                <a:off x="8418234" y="2870573"/>
-                <a:ext cx="236035" cy="236035"/>
+                <a:off x="8137032" y="2925454"/>
+                <a:ext cx="200881" cy="200881"/>
               </a:xfrm>
               <a:prstGeom prst="rect">
                 <a:avLst/>
@@ -7711,17 +7603,13 @@
               <p:nvPr/>
             </p:nvGraphicFramePr>
             <p:xfrm>
-              <a:off x="8211123" y="2506375"/>
-              <a:ext cx="630042" cy="630042"/>
+              <a:off x="7960767" y="2615498"/>
+              <a:ext cx="536206" cy="536206"/>
             </p:xfrm>
             <a:graphic>
               <a:graphicData uri="http://schemas.microsoft.com/office/drawing/2017/model3d">
                 <am3d:model3d r:embed="rId18">
                   <am3d:spPr>
-                    <a:xfrm>
-                      <a:off x="8211123" y="2506375"/>
-                      <a:ext cx="630042" cy="630042"/>
-                    </a:xfrm>
                     <a:prstGeom prst="rect">
                       <a:avLst/>
                     </a:prstGeom>
@@ -7746,7 +7634,7 @@
                   <am3d:raster rName="Office3DRenderer" rVer="16.0.8326">
                     <am3d:blip r:embed="rId5"/>
                   </am3d:raster>
-                  <am3d:objViewport viewportSz="630042"/>
+                  <am3d:objViewport viewportSz="536206"/>
                   <am3d:ambientLight>
                     <am3d:clr>
                       <a:scrgbClr r="50000" g="50000" b="50000"/>
@@ -7796,8 +7684,8 @@
             </p:blipFill>
             <p:spPr>
               <a:xfrm>
-                <a:off x="8211123" y="2506375"/>
-                <a:ext cx="630042" cy="630042"/>
+                <a:off x="7960767" y="2615498"/>
+                <a:ext cx="536206" cy="536206"/>
               </a:xfrm>
               <a:prstGeom prst="rect">
                 <a:avLst/>
@@ -7817,17 +7705,13 @@
               <p:nvPr/>
             </p:nvGraphicFramePr>
             <p:xfrm>
-              <a:off x="8291995" y="2263477"/>
-              <a:ext cx="1039873" cy="1039873"/>
+              <a:off x="8029594" y="2408776"/>
+              <a:ext cx="884999" cy="884999"/>
             </p:xfrm>
             <a:graphic>
               <a:graphicData uri="http://schemas.microsoft.com/office/drawing/2017/model3d">
                 <am3d:model3d r:embed="rId19">
                   <am3d:spPr>
-                    <a:xfrm>
-                      <a:off x="8291995" y="2263477"/>
-                      <a:ext cx="1039873" cy="1039873"/>
-                    </a:xfrm>
                     <a:prstGeom prst="rect">
                       <a:avLst/>
                     </a:prstGeom>
@@ -7852,7 +7736,7 @@
                   <am3d:raster rName="Office3DRenderer" rVer="16.0.8326">
                     <am3d:blip r:embed="rId6"/>
                   </am3d:raster>
-                  <am3d:objViewport viewportSz="1039873"/>
+                  <am3d:objViewport viewportSz="884999"/>
                   <am3d:ambientLight>
                     <am3d:clr>
                       <a:scrgbClr r="50000" g="50000" b="50000"/>
@@ -7902,8 +7786,8 @@
             </p:blipFill>
             <p:spPr>
               <a:xfrm>
-                <a:off x="8291995" y="2263477"/>
-                <a:ext cx="1039873" cy="1039873"/>
+                <a:off x="8029594" y="2408776"/>
+                <a:ext cx="884999" cy="884999"/>
               </a:xfrm>
               <a:prstGeom prst="rect">
                 <a:avLst/>
@@ -7923,17 +7807,13 @@
               <p:nvPr/>
             </p:nvGraphicFramePr>
             <p:xfrm>
-              <a:off x="4381214" y="2704934"/>
-              <a:ext cx="3807615" cy="3807615"/>
+              <a:off x="4701270" y="2784484"/>
+              <a:ext cx="3240523" cy="3240523"/>
             </p:xfrm>
             <a:graphic>
               <a:graphicData uri="http://schemas.microsoft.com/office/drawing/2017/model3d">
                 <am3d:model3d r:embed="rId20">
                   <am3d:spPr>
-                    <a:xfrm>
-                      <a:off x="4381214" y="2704934"/>
-                      <a:ext cx="3807615" cy="3807615"/>
-                    </a:xfrm>
                     <a:prstGeom prst="rect">
                       <a:avLst/>
                     </a:prstGeom>
@@ -7958,7 +7838,7 @@
                   <am3d:raster rName="Office3DRenderer" rVer="16.0.8326">
                     <am3d:blip r:embed="rId7"/>
                   </am3d:raster>
-                  <am3d:objViewport viewportSz="3807615"/>
+                  <am3d:objViewport viewportSz="3240523"/>
                   <am3d:ambientLight>
                     <am3d:clr>
                       <a:scrgbClr r="50000" g="50000" b="50000"/>
@@ -8008,8 +7888,8 @@
             </p:blipFill>
             <p:spPr>
               <a:xfrm>
-                <a:off x="4381214" y="2704934"/>
-                <a:ext cx="3807615" cy="3807615"/>
+                <a:off x="4701270" y="2784484"/>
+                <a:ext cx="3240523" cy="3240523"/>
               </a:xfrm>
               <a:prstGeom prst="rect">
                 <a:avLst/>
@@ -8029,17 +7909,13 @@
               <p:nvPr/>
             </p:nvGraphicFramePr>
             <p:xfrm>
-              <a:off x="6499029" y="4139361"/>
-              <a:ext cx="773169" cy="773169"/>
+              <a:off x="6503666" y="4005274"/>
+              <a:ext cx="658016" cy="658016"/>
             </p:xfrm>
             <a:graphic>
               <a:graphicData uri="http://schemas.microsoft.com/office/drawing/2017/model3d">
                 <am3d:model3d r:embed="rId21">
                   <am3d:spPr>
-                    <a:xfrm>
-                      <a:off x="6499029" y="4139361"/>
-                      <a:ext cx="773169" cy="773169"/>
-                    </a:xfrm>
                     <a:prstGeom prst="rect">
                       <a:avLst/>
                     </a:prstGeom>
@@ -8064,7 +7940,7 @@
                   <am3d:raster rName="Office3DRenderer" rVer="16.0.8326">
                     <am3d:blip r:embed="rId8"/>
                   </am3d:raster>
-                  <am3d:objViewport viewportSz="773169"/>
+                  <am3d:objViewport viewportSz="658016"/>
                   <am3d:ambientLight>
                     <am3d:clr>
                       <a:scrgbClr r="50000" g="50000" b="50000"/>
@@ -8114,8 +7990,8 @@
             </p:blipFill>
             <p:spPr>
               <a:xfrm>
-                <a:off x="6499029" y="4139361"/>
-                <a:ext cx="773169" cy="773169"/>
+                <a:off x="6503666" y="4005274"/>
+                <a:ext cx="658016" cy="658016"/>
               </a:xfrm>
               <a:prstGeom prst="rect">
                 <a:avLst/>
@@ -8135,17 +8011,13 @@
               <p:nvPr/>
             </p:nvGraphicFramePr>
             <p:xfrm>
-              <a:off x="6696693" y="4337025"/>
-              <a:ext cx="377842" cy="377842"/>
+              <a:off x="6671890" y="4173498"/>
+              <a:ext cx="321567" cy="321567"/>
             </p:xfrm>
             <a:graphic>
               <a:graphicData uri="http://schemas.microsoft.com/office/drawing/2017/model3d">
                 <am3d:model3d r:embed="rId22">
                   <am3d:spPr>
-                    <a:xfrm>
-                      <a:off x="6696693" y="4337025"/>
-                      <a:ext cx="377842" cy="377842"/>
-                    </a:xfrm>
                     <a:prstGeom prst="rect">
                       <a:avLst/>
                     </a:prstGeom>
@@ -8170,7 +8042,7 @@
                   <am3d:raster rName="Office3DRenderer" rVer="16.0.8326">
                     <am3d:blip r:embed="rId9"/>
                   </am3d:raster>
-                  <am3d:objViewport viewportSz="377842"/>
+                  <am3d:objViewport viewportSz="321567"/>
                   <am3d:ambientLight>
                     <am3d:clr>
                       <a:scrgbClr r="50000" g="50000" b="50000"/>
@@ -8220,8 +8092,8 @@
             </p:blipFill>
             <p:spPr>
               <a:xfrm>
-                <a:off x="6696693" y="4337025"/>
-                <a:ext cx="377842" cy="377842"/>
+                <a:off x="6671890" y="4173498"/>
+                <a:ext cx="321567" cy="321567"/>
               </a:xfrm>
               <a:prstGeom prst="rect">
                 <a:avLst/>
@@ -8241,17 +8113,13 @@
               <p:nvPr/>
             </p:nvGraphicFramePr>
             <p:xfrm>
-              <a:off x="6696693" y="4337025"/>
-              <a:ext cx="377842" cy="377842"/>
+              <a:off x="6671890" y="4173498"/>
+              <a:ext cx="321567" cy="321567"/>
             </p:xfrm>
             <a:graphic>
               <a:graphicData uri="http://schemas.microsoft.com/office/drawing/2017/model3d">
                 <am3d:model3d r:embed="rId23">
                   <am3d:spPr>
-                    <a:xfrm>
-                      <a:off x="6696693" y="4337025"/>
-                      <a:ext cx="377842" cy="377842"/>
-                    </a:xfrm>
                     <a:prstGeom prst="rect">
                       <a:avLst/>
                     </a:prstGeom>
@@ -8276,7 +8144,7 @@
                   <am3d:raster rName="Office3DRenderer" rVer="16.0.8326">
                     <am3d:blip r:embed="rId10"/>
                   </am3d:raster>
-                  <am3d:objViewport viewportSz="377842"/>
+                  <am3d:objViewport viewportSz="321567"/>
                   <am3d:ambientLight>
                     <am3d:clr>
                       <a:scrgbClr r="50000" g="50000" b="50000"/>
@@ -8326,8 +8194,8 @@
             </p:blipFill>
             <p:spPr>
               <a:xfrm>
-                <a:off x="6696693" y="4337025"/>
-                <a:ext cx="377842" cy="377842"/>
+                <a:off x="6671890" y="4173498"/>
+                <a:ext cx="321567" cy="321567"/>
               </a:xfrm>
               <a:prstGeom prst="rect">
                 <a:avLst/>
@@ -8347,17 +8215,13 @@
               <p:nvPr/>
             </p:nvGraphicFramePr>
             <p:xfrm>
-              <a:off x="6696693" y="4337025"/>
-              <a:ext cx="377842" cy="377842"/>
+              <a:off x="6671890" y="4173498"/>
+              <a:ext cx="321567" cy="321567"/>
             </p:xfrm>
             <a:graphic>
               <a:graphicData uri="http://schemas.microsoft.com/office/drawing/2017/model3d">
                 <am3d:model3d r:embed="rId24">
                   <am3d:spPr>
-                    <a:xfrm>
-                      <a:off x="6696693" y="4337025"/>
-                      <a:ext cx="377842" cy="377842"/>
-                    </a:xfrm>
                     <a:prstGeom prst="rect">
                       <a:avLst/>
                     </a:prstGeom>
@@ -8382,7 +8246,7 @@
                   <am3d:raster rName="Office3DRenderer" rVer="16.0.8326">
                     <am3d:blip r:embed="rId11"/>
                   </am3d:raster>
-                  <am3d:objViewport viewportSz="377842"/>
+                  <am3d:objViewport viewportSz="321567"/>
                   <am3d:ambientLight>
                     <am3d:clr>
                       <a:scrgbClr r="50000" g="50000" b="50000"/>
@@ -8432,8 +8296,8 @@
             </p:blipFill>
             <p:spPr>
               <a:xfrm>
-                <a:off x="6696693" y="4337025"/>
-                <a:ext cx="377842" cy="377842"/>
+                <a:off x="6671890" y="4173498"/>
+                <a:ext cx="321567" cy="321567"/>
               </a:xfrm>
               <a:prstGeom prst="rect">
                 <a:avLst/>
@@ -8453,17 +8317,13 @@
               <p:nvPr/>
             </p:nvGraphicFramePr>
             <p:xfrm>
-              <a:off x="6696693" y="4337025"/>
-              <a:ext cx="377842" cy="377842"/>
+              <a:off x="6671890" y="4173498"/>
+              <a:ext cx="321567" cy="321567"/>
             </p:xfrm>
             <a:graphic>
               <a:graphicData uri="http://schemas.microsoft.com/office/drawing/2017/model3d">
                 <am3d:model3d r:embed="rId25">
                   <am3d:spPr>
-                    <a:xfrm>
-                      <a:off x="6696693" y="4337025"/>
-                      <a:ext cx="377842" cy="377842"/>
-                    </a:xfrm>
                     <a:prstGeom prst="rect">
                       <a:avLst/>
                     </a:prstGeom>
@@ -8488,7 +8348,7 @@
                   <am3d:raster rName="Office3DRenderer" rVer="16.0.8326">
                     <am3d:blip r:embed="rId12"/>
                   </am3d:raster>
-                  <am3d:objViewport viewportSz="377842"/>
+                  <am3d:objViewport viewportSz="321567"/>
                   <am3d:ambientLight>
                     <am3d:clr>
                       <a:scrgbClr r="50000" g="50000" b="50000"/>
@@ -8538,8 +8398,8 @@
             </p:blipFill>
             <p:spPr>
               <a:xfrm>
-                <a:off x="6696693" y="4337025"/>
-                <a:ext cx="377842" cy="377842"/>
+                <a:off x="6671890" y="4173498"/>
+                <a:ext cx="321567" cy="321567"/>
               </a:xfrm>
               <a:prstGeom prst="rect">
                 <a:avLst/>
@@ -8559,17 +8419,13 @@
               <p:nvPr/>
             </p:nvGraphicFramePr>
             <p:xfrm>
-              <a:off x="7411833" y="-280205"/>
-              <a:ext cx="5633146" cy="5633146"/>
+              <a:off x="7280520" y="243940"/>
+              <a:ext cx="4794167" cy="4794167"/>
             </p:xfrm>
             <a:graphic>
               <a:graphicData uri="http://schemas.microsoft.com/office/drawing/2017/model3d">
                 <am3d:model3d r:embed="rId26">
                   <am3d:spPr>
-                    <a:xfrm>
-                      <a:off x="7411833" y="-280205"/>
-                      <a:ext cx="5633146" cy="5633146"/>
-                    </a:xfrm>
                     <a:prstGeom prst="rect">
                       <a:avLst/>
                     </a:prstGeom>
@@ -8594,7 +8450,7 @@
                   <am3d:raster rName="Office3DRenderer" rVer="16.0.8326">
                     <am3d:blip r:embed="rId13"/>
                   </am3d:raster>
-                  <am3d:objViewport viewportSz="5633146"/>
+                  <am3d:objViewport viewportSz="4794167"/>
                   <am3d:ambientLight>
                     <am3d:clr>
                       <a:scrgbClr r="50000" g="50000" b="50000"/>
@@ -8644,8 +8500,8 @@
             </p:blipFill>
             <p:spPr>
               <a:xfrm>
-                <a:off x="7411833" y="-280205"/>
-                <a:ext cx="5633146" cy="5633146"/>
+                <a:off x="7280520" y="243940"/>
+                <a:ext cx="4794167" cy="4794167"/>
               </a:xfrm>
               <a:prstGeom prst="rect">
                 <a:avLst/>
@@ -9254,8 +9110,8 @@
         </p:blipFill>
         <p:spPr>
           <a:xfrm>
-            <a:off x="6645304" y="2985020"/>
-            <a:ext cx="1450238" cy="1450238"/>
+            <a:off x="6978672" y="3049225"/>
+            <a:ext cx="1093622" cy="1093622"/>
           </a:xfrm>
           <a:prstGeom prst="rect">
             <a:avLst/>
@@ -9273,17 +9129,13 @@
               <p:nvPr/>
             </p:nvGraphicFramePr>
             <p:xfrm>
-              <a:off x="7217252" y="3556968"/>
-              <a:ext cx="306343" cy="306343"/>
+              <a:off x="7409977" y="3480530"/>
+              <a:ext cx="231013" cy="231013"/>
             </p:xfrm>
             <a:graphic>
               <a:graphicData uri="http://schemas.microsoft.com/office/drawing/2017/model3d">
                 <am3d:model3d r:embed="rId10">
                   <am3d:spPr>
-                    <a:xfrm>
-                      <a:off x="7217252" y="3556968"/>
-                      <a:ext cx="306343" cy="306343"/>
-                    </a:xfrm>
                     <a:prstGeom prst="rect">
                       <a:avLst/>
                     </a:prstGeom>
@@ -9308,7 +9160,7 @@
                   <am3d:raster rName="Office3DRenderer" rVer="16.0.8326">
                     <am3d:blip r:embed="rId3"/>
                   </am3d:raster>
-                  <am3d:objViewport viewportSz="306343"/>
+                  <am3d:objViewport viewportSz="231013"/>
                   <am3d:ambientLight>
                     <am3d:clr>
                       <a:scrgbClr r="50000" g="50000" b="50000"/>
@@ -9358,8 +9210,8 @@
             </p:blipFill>
             <p:spPr>
               <a:xfrm>
-                <a:off x="7217252" y="3556968"/>
-                <a:ext cx="306343" cy="306343"/>
+                <a:off x="7409977" y="3480530"/>
+                <a:ext cx="231013" cy="231013"/>
               </a:xfrm>
               <a:prstGeom prst="rect">
                 <a:avLst/>
@@ -9379,17 +9231,13 @@
               <p:nvPr/>
             </p:nvGraphicFramePr>
             <p:xfrm>
-              <a:off x="7063268" y="2762882"/>
-              <a:ext cx="1349623" cy="1349623"/>
+              <a:off x="7293858" y="2881711"/>
+              <a:ext cx="1017748" cy="1017748"/>
             </p:xfrm>
             <a:graphic>
               <a:graphicData uri="http://schemas.microsoft.com/office/drawing/2017/model3d">
                 <am3d:model3d r:embed="rId11">
                   <am3d:spPr>
-                    <a:xfrm>
-                      <a:off x="7063268" y="2762882"/>
-                      <a:ext cx="1349623" cy="1349623"/>
-                    </a:xfrm>
                     <a:prstGeom prst="rect">
                       <a:avLst/>
                     </a:prstGeom>
@@ -9414,7 +9262,7 @@
                   <am3d:raster rName="Office3DRenderer" rVer="16.0.8326">
                     <am3d:blip r:embed="rId4"/>
                   </am3d:raster>
-                  <am3d:objViewport viewportSz="1349623"/>
+                  <am3d:objViewport viewportSz="1017748"/>
                   <am3d:ambientLight>
                     <am3d:clr>
                       <a:scrgbClr r="50000" g="50000" b="50000"/>
@@ -9464,8 +9312,8 @@
             </p:blipFill>
             <p:spPr>
               <a:xfrm>
-                <a:off x="7063268" y="2762882"/>
-                <a:ext cx="1349623" cy="1349623"/>
+                <a:off x="7293858" y="2881711"/>
+                <a:ext cx="1017748" cy="1017748"/>
               </a:xfrm>
               <a:prstGeom prst="rect">
                 <a:avLst/>
@@ -9485,17 +9333,13 @@
               <p:nvPr/>
             </p:nvGraphicFramePr>
             <p:xfrm>
-              <a:off x="6960282" y="3081715"/>
-              <a:ext cx="817714" cy="817714"/>
+              <a:off x="7216196" y="3122143"/>
+              <a:ext cx="616637" cy="616637"/>
             </p:xfrm>
             <a:graphic>
               <a:graphicData uri="http://schemas.microsoft.com/office/drawing/2017/model3d">
                 <am3d:model3d r:embed="rId12">
                   <am3d:spPr>
-                    <a:xfrm>
-                      <a:off x="6960282" y="3081715"/>
-                      <a:ext cx="817714" cy="817714"/>
-                    </a:xfrm>
                     <a:prstGeom prst="rect">
                       <a:avLst/>
                     </a:prstGeom>
@@ -9520,7 +9364,7 @@
                   <am3d:raster rName="Office3DRenderer" rVer="16.0.8326">
                     <am3d:blip r:embed="rId5"/>
                   </am3d:raster>
-                  <am3d:objViewport viewportSz="817714"/>
+                  <am3d:objViewport viewportSz="616637"/>
                   <am3d:ambientLight>
                     <am3d:clr>
                       <a:scrgbClr r="50000" g="50000" b="50000"/>
@@ -9570,8 +9414,8 @@
             </p:blipFill>
             <p:spPr>
               <a:xfrm>
-                <a:off x="6960282" y="3081715"/>
-                <a:ext cx="817714" cy="817714"/>
+                <a:off x="7216196" y="3122143"/>
+                <a:ext cx="616637" cy="616637"/>
               </a:xfrm>
               <a:prstGeom prst="rect">
                 <a:avLst/>
@@ -9591,17 +9435,13 @@
               <p:nvPr/>
             </p:nvGraphicFramePr>
             <p:xfrm>
-              <a:off x="4000957" y="1142112"/>
-              <a:ext cx="4561250" cy="4561250"/>
+              <a:off x="4984574" y="1659491"/>
+              <a:ext cx="3439631" cy="3439631"/>
             </p:xfrm>
             <a:graphic>
               <a:graphicData uri="http://schemas.microsoft.com/office/drawing/2017/model3d">
                 <am3d:model3d r:embed="rId13">
                   <am3d:spPr>
-                    <a:xfrm>
-                      <a:off x="4000957" y="1142112"/>
-                      <a:ext cx="4561250" cy="4561250"/>
-                    </a:xfrm>
                     <a:prstGeom prst="rect">
                       <a:avLst/>
                     </a:prstGeom>
@@ -9626,7 +9466,7 @@
                   <am3d:raster rName="Office3DRenderer" rVer="16.0.8326">
                     <am3d:blip r:embed="rId6"/>
                   </am3d:raster>
-                  <am3d:objViewport viewportSz="4561250"/>
+                  <am3d:objViewport viewportSz="3439631"/>
                   <am3d:ambientLight>
                     <am3d:clr>
                       <a:scrgbClr r="50000" g="50000" b="50000"/>
@@ -9676,8 +9516,8 @@
             </p:blipFill>
             <p:spPr>
               <a:xfrm>
-                <a:off x="4000957" y="1142112"/>
-                <a:ext cx="4561250" cy="4561250"/>
+                <a:off x="4984574" y="1659491"/>
+                <a:ext cx="3439631" cy="3439631"/>
               </a:xfrm>
               <a:prstGeom prst="rect">
                 <a:avLst/>
@@ -9697,17 +9537,13 @@
               <p:nvPr/>
             </p:nvGraphicFramePr>
             <p:xfrm>
-              <a:off x="6064866" y="-586050"/>
-              <a:ext cx="7311105" cy="7311105"/>
+              <a:off x="6540965" y="356287"/>
+              <a:ext cx="5513292" cy="5513292"/>
             </p:xfrm>
             <a:graphic>
               <a:graphicData uri="http://schemas.microsoft.com/office/drawing/2017/model3d">
                 <am3d:model3d r:embed="rId14">
                   <am3d:spPr>
-                    <a:xfrm>
-                      <a:off x="6064866" y="-586050"/>
-                      <a:ext cx="7311105" cy="7311105"/>
-                    </a:xfrm>
                     <a:prstGeom prst="rect">
                       <a:avLst/>
                     </a:prstGeom>
@@ -9732,7 +9568,7 @@
                   <am3d:raster rName="Office3DRenderer" rVer="16.0.8326">
                     <am3d:blip r:embed="rId7"/>
                   </am3d:raster>
-                  <am3d:objViewport viewportSz="7311105"/>
+                  <am3d:objViewport viewportSz="5513292"/>
                   <am3d:ambientLight>
                     <am3d:clr>
                       <a:scrgbClr r="50000" g="50000" b="50000"/>
@@ -9782,8 +9618,8 @@
             </p:blipFill>
             <p:spPr>
               <a:xfrm>
-                <a:off x="6064866" y="-586050"/>
-                <a:ext cx="7311105" cy="7311105"/>
+                <a:off x="6540965" y="356287"/>
+                <a:ext cx="5513292" cy="5513292"/>
               </a:xfrm>
               <a:prstGeom prst="rect">
                 <a:avLst/>

</xml_diff>